<commit_message>
Pring agent information in main GUI
</commit_message>
<xml_diff>
--- a/examples/images/legend.pptx
+++ b/examples/images/legend.pptx
@@ -104,6 +104,11 @@
       </a:defRPr>
     </a:lvl9pPr>
   </p:defaultTextStyle>
+  <p:extLst>
+    <p:ext uri="{EFAFB233-063F-42B5-8137-9DF3F51BA10A}">
+      <p15:sldGuideLst xmlns:p15="http://schemas.microsoft.com/office/powerpoint/2012/main"/>
+    </p:ext>
+  </p:extLst>
 </p:presentation>
 </file>
 
@@ -3321,6 +3326,762 @@
           <a:chExt cx="0" cy="0"/>
         </a:xfrm>
       </p:grpSpPr>
+      <p:grpSp>
+        <p:nvGrpSpPr>
+          <p:cNvPr id="24" name="Group 23">
+            <a:extLst>
+              <a:ext uri="{FF2B5EF4-FFF2-40B4-BE49-F238E27FC236}">
+                <a16:creationId xmlns:a16="http://schemas.microsoft.com/office/drawing/2014/main" id="{FF3832F4-9D8E-784C-F05E-0E18A076EF7D}"/>
+              </a:ext>
+            </a:extLst>
+          </p:cNvPr>
+          <p:cNvGrpSpPr/>
+          <p:nvPr/>
+        </p:nvGrpSpPr>
+        <p:grpSpPr>
+          <a:xfrm>
+            <a:off x="1971675" y="2247900"/>
+            <a:ext cx="7269480" cy="1828800"/>
+            <a:chOff x="1971675" y="2247900"/>
+            <a:chExt cx="7269480" cy="1828800"/>
+          </a:xfrm>
+        </p:grpSpPr>
+        <p:sp>
+          <p:nvSpPr>
+            <p:cNvPr id="3" name="Rectangle 2">
+              <a:extLst>
+                <a:ext uri="{FF2B5EF4-FFF2-40B4-BE49-F238E27FC236}">
+                  <a16:creationId xmlns:a16="http://schemas.microsoft.com/office/drawing/2014/main" id="{EB9A7F82-A768-2361-2BBB-09D976419C18}"/>
+                </a:ext>
+              </a:extLst>
+            </p:cNvPr>
+            <p:cNvSpPr/>
+            <p:nvPr/>
+          </p:nvSpPr>
+          <p:spPr>
+            <a:xfrm>
+              <a:off x="1971675" y="2247900"/>
+              <a:ext cx="7269480" cy="1828800"/>
+            </a:xfrm>
+            <a:prstGeom prst="rect">
+              <a:avLst/>
+            </a:prstGeom>
+            <a:solidFill>
+              <a:schemeClr val="bg1"/>
+            </a:solidFill>
+            <a:ln>
+              <a:noFill/>
+            </a:ln>
+          </p:spPr>
+          <p:style>
+            <a:lnRef idx="2">
+              <a:schemeClr val="accent1">
+                <a:shade val="15000"/>
+              </a:schemeClr>
+            </a:lnRef>
+            <a:fillRef idx="1">
+              <a:schemeClr val="accent1"/>
+            </a:fillRef>
+            <a:effectRef idx="0">
+              <a:schemeClr val="accent1"/>
+            </a:effectRef>
+            <a:fontRef idx="minor">
+              <a:schemeClr val="lt1"/>
+            </a:fontRef>
+          </p:style>
+          <p:txBody>
+            <a:bodyPr rtlCol="0" anchor="ctr"/>
+            <a:lstStyle/>
+            <a:p>
+              <a:pPr algn="ctr"/>
+              <a:endParaRPr lang="en-US">
+                <a:ln>
+                  <a:solidFill>
+                    <a:schemeClr val="bg1"/>
+                  </a:solidFill>
+                </a:ln>
+              </a:endParaRPr>
+            </a:p>
+          </p:txBody>
+        </p:sp>
+        <p:pic>
+          <p:nvPicPr>
+            <p:cNvPr id="5" name="Picture 4" descr="A red logo with black background&#10;&#10;AI-generated content may be incorrect.">
+              <a:extLst>
+                <a:ext uri="{FF2B5EF4-FFF2-40B4-BE49-F238E27FC236}">
+                  <a16:creationId xmlns:a16="http://schemas.microsoft.com/office/drawing/2014/main" id="{840086B9-B26D-FB5B-4FE0-DD18173D3872}"/>
+                </a:ext>
+              </a:extLst>
+            </p:cNvPr>
+            <p:cNvPicPr>
+              <a:picLocks noChangeAspect="1"/>
+            </p:cNvPicPr>
+            <p:nvPr/>
+          </p:nvPicPr>
+          <p:blipFill>
+            <a:blip r:embed="rId2">
+              <a:extLst>
+                <a:ext uri="{28A0092B-C50C-407E-A947-70E740481C1C}">
+                  <a14:useLocalDpi xmlns:a14="http://schemas.microsoft.com/office/drawing/2010/main" val="0"/>
+                </a:ext>
+              </a:extLst>
+            </a:blip>
+            <a:stretch>
+              <a:fillRect/>
+            </a:stretch>
+          </p:blipFill>
+          <p:spPr>
+            <a:xfrm>
+              <a:off x="2232980" y="2680502"/>
+              <a:ext cx="408677" cy="469765"/>
+            </a:xfrm>
+            <a:prstGeom prst="rect">
+              <a:avLst/>
+            </a:prstGeom>
+          </p:spPr>
+        </p:pic>
+        <p:pic>
+          <p:nvPicPr>
+            <p:cNvPr id="7" name="Picture 6" descr="A yellow van with blue wheels&#10;&#10;AI-generated content may be incorrect.">
+              <a:extLst>
+                <a:ext uri="{FF2B5EF4-FFF2-40B4-BE49-F238E27FC236}">
+                  <a16:creationId xmlns:a16="http://schemas.microsoft.com/office/drawing/2014/main" id="{38C463D4-84F1-C2E0-A90C-1D8AF773B286}"/>
+                </a:ext>
+              </a:extLst>
+            </p:cNvPr>
+            <p:cNvPicPr>
+              <a:picLocks noChangeAspect="1"/>
+            </p:cNvPicPr>
+            <p:nvPr/>
+          </p:nvPicPr>
+          <p:blipFill>
+            <a:blip r:embed="rId3">
+              <a:extLst>
+                <a:ext uri="{28A0092B-C50C-407E-A947-70E740481C1C}">
+                  <a14:useLocalDpi xmlns:a14="http://schemas.microsoft.com/office/drawing/2010/main" val="0"/>
+                </a:ext>
+              </a:extLst>
+            </a:blip>
+            <a:stretch>
+              <a:fillRect/>
+            </a:stretch>
+          </p:blipFill>
+          <p:spPr>
+            <a:xfrm>
+              <a:off x="2855036" y="2541679"/>
+              <a:ext cx="697630" cy="697630"/>
+            </a:xfrm>
+            <a:prstGeom prst="rect">
+              <a:avLst/>
+            </a:prstGeom>
+          </p:spPr>
+        </p:pic>
+        <p:sp>
+          <p:nvSpPr>
+            <p:cNvPr id="8" name="Oval 7">
+              <a:extLst>
+                <a:ext uri="{FF2B5EF4-FFF2-40B4-BE49-F238E27FC236}">
+                  <a16:creationId xmlns:a16="http://schemas.microsoft.com/office/drawing/2014/main" id="{CEAA036B-44A6-D915-C78B-AC8AF9584BBB}"/>
+                </a:ext>
+              </a:extLst>
+            </p:cNvPr>
+            <p:cNvSpPr/>
+            <p:nvPr/>
+          </p:nvSpPr>
+          <p:spPr>
+            <a:xfrm>
+              <a:off x="5781273" y="2680502"/>
+              <a:ext cx="400050" cy="400050"/>
+            </a:xfrm>
+            <a:prstGeom prst="ellipse">
+              <a:avLst/>
+            </a:prstGeom>
+            <a:solidFill>
+              <a:srgbClr val="0000FF"/>
+            </a:solidFill>
+            <a:ln>
+              <a:noFill/>
+            </a:ln>
+          </p:spPr>
+          <p:style>
+            <a:lnRef idx="2">
+              <a:schemeClr val="accent1">
+                <a:shade val="15000"/>
+              </a:schemeClr>
+            </a:lnRef>
+            <a:fillRef idx="1">
+              <a:schemeClr val="accent1"/>
+            </a:fillRef>
+            <a:effectRef idx="0">
+              <a:schemeClr val="accent1"/>
+            </a:effectRef>
+            <a:fontRef idx="minor">
+              <a:schemeClr val="lt1"/>
+            </a:fontRef>
+          </p:style>
+          <p:txBody>
+            <a:bodyPr rtlCol="0" anchor="ctr"/>
+            <a:lstStyle/>
+            <a:p>
+              <a:pPr algn="ctr"/>
+              <a:endParaRPr lang="en-US" dirty="0"/>
+            </a:p>
+          </p:txBody>
+        </p:sp>
+        <p:sp>
+          <p:nvSpPr>
+            <p:cNvPr id="9" name="Oval 8">
+              <a:extLst>
+                <a:ext uri="{FF2B5EF4-FFF2-40B4-BE49-F238E27FC236}">
+                  <a16:creationId xmlns:a16="http://schemas.microsoft.com/office/drawing/2014/main" id="{AB5E8D7C-0D86-3E54-74C8-3CF0A65BECC1}"/>
+                </a:ext>
+              </a:extLst>
+            </p:cNvPr>
+            <p:cNvSpPr/>
+            <p:nvPr/>
+          </p:nvSpPr>
+          <p:spPr>
+            <a:xfrm>
+              <a:off x="6710096" y="2694888"/>
+              <a:ext cx="400050" cy="400050"/>
+            </a:xfrm>
+            <a:prstGeom prst="ellipse">
+              <a:avLst/>
+            </a:prstGeom>
+            <a:solidFill>
+              <a:srgbClr val="FFC202"/>
+            </a:solidFill>
+            <a:ln>
+              <a:noFill/>
+            </a:ln>
+          </p:spPr>
+          <p:style>
+            <a:lnRef idx="2">
+              <a:schemeClr val="accent1">
+                <a:shade val="15000"/>
+              </a:schemeClr>
+            </a:lnRef>
+            <a:fillRef idx="1">
+              <a:schemeClr val="accent1"/>
+            </a:fillRef>
+            <a:effectRef idx="0">
+              <a:schemeClr val="accent1"/>
+            </a:effectRef>
+            <a:fontRef idx="minor">
+              <a:schemeClr val="lt1"/>
+            </a:fontRef>
+          </p:style>
+          <p:txBody>
+            <a:bodyPr rtlCol="0" anchor="ctr"/>
+            <a:lstStyle/>
+            <a:p>
+              <a:pPr algn="ctr"/>
+              <a:endParaRPr lang="en-US"/>
+            </a:p>
+          </p:txBody>
+        </p:sp>
+        <p:sp>
+          <p:nvSpPr>
+            <p:cNvPr id="10" name="Oval 9">
+              <a:extLst>
+                <a:ext uri="{FF2B5EF4-FFF2-40B4-BE49-F238E27FC236}">
+                  <a16:creationId xmlns:a16="http://schemas.microsoft.com/office/drawing/2014/main" id="{E082E04B-0A60-4000-4071-CE4F652A1795}"/>
+                </a:ext>
+              </a:extLst>
+            </p:cNvPr>
+            <p:cNvSpPr/>
+            <p:nvPr/>
+          </p:nvSpPr>
+          <p:spPr>
+            <a:xfrm>
+              <a:off x="7638918" y="2690469"/>
+              <a:ext cx="400050" cy="400050"/>
+            </a:xfrm>
+            <a:prstGeom prst="ellipse">
+              <a:avLst/>
+            </a:prstGeom>
+            <a:solidFill>
+              <a:srgbClr val="FF0000"/>
+            </a:solidFill>
+            <a:ln>
+              <a:noFill/>
+            </a:ln>
+          </p:spPr>
+          <p:style>
+            <a:lnRef idx="2">
+              <a:schemeClr val="accent1">
+                <a:shade val="15000"/>
+              </a:schemeClr>
+            </a:lnRef>
+            <a:fillRef idx="1">
+              <a:schemeClr val="accent1"/>
+            </a:fillRef>
+            <a:effectRef idx="0">
+              <a:schemeClr val="accent1"/>
+            </a:effectRef>
+            <a:fontRef idx="minor">
+              <a:schemeClr val="lt1"/>
+            </a:fontRef>
+          </p:style>
+          <p:txBody>
+            <a:bodyPr rtlCol="0" anchor="ctr"/>
+            <a:lstStyle/>
+            <a:p>
+              <a:pPr algn="ctr"/>
+              <a:endParaRPr lang="en-US"/>
+            </a:p>
+          </p:txBody>
+        </p:sp>
+        <p:sp>
+          <p:nvSpPr>
+            <p:cNvPr id="11" name="Oval 10">
+              <a:extLst>
+                <a:ext uri="{FF2B5EF4-FFF2-40B4-BE49-F238E27FC236}">
+                  <a16:creationId xmlns:a16="http://schemas.microsoft.com/office/drawing/2014/main" id="{5A41FAF3-F094-9365-6971-7BBBB4F8E305}"/>
+                </a:ext>
+              </a:extLst>
+            </p:cNvPr>
+            <p:cNvSpPr/>
+            <p:nvPr/>
+          </p:nvSpPr>
+          <p:spPr>
+            <a:xfrm>
+              <a:off x="8567740" y="2690469"/>
+              <a:ext cx="400050" cy="400050"/>
+            </a:xfrm>
+            <a:prstGeom prst="ellipse">
+              <a:avLst/>
+            </a:prstGeom>
+            <a:solidFill>
+              <a:srgbClr val="0077BE"/>
+            </a:solidFill>
+            <a:ln>
+              <a:noFill/>
+            </a:ln>
+          </p:spPr>
+          <p:style>
+            <a:lnRef idx="2">
+              <a:schemeClr val="accent1">
+                <a:shade val="15000"/>
+              </a:schemeClr>
+            </a:lnRef>
+            <a:fillRef idx="1">
+              <a:schemeClr val="accent1"/>
+            </a:fillRef>
+            <a:effectRef idx="0">
+              <a:schemeClr val="accent1"/>
+            </a:effectRef>
+            <a:fontRef idx="minor">
+              <a:schemeClr val="lt1"/>
+            </a:fontRef>
+          </p:style>
+          <p:txBody>
+            <a:bodyPr rtlCol="0" anchor="ctr"/>
+            <a:lstStyle/>
+            <a:p>
+              <a:pPr algn="ctr"/>
+              <a:endParaRPr lang="en-US"/>
+            </a:p>
+          </p:txBody>
+        </p:sp>
+        <p:sp>
+          <p:nvSpPr>
+            <p:cNvPr id="12" name="Oval 11">
+              <a:extLst>
+                <a:ext uri="{FF2B5EF4-FFF2-40B4-BE49-F238E27FC236}">
+                  <a16:creationId xmlns:a16="http://schemas.microsoft.com/office/drawing/2014/main" id="{C7FAB00C-9945-017D-7B4D-74FD63923081}"/>
+                </a:ext>
+              </a:extLst>
+            </p:cNvPr>
+            <p:cNvSpPr/>
+            <p:nvPr/>
+          </p:nvSpPr>
+          <p:spPr>
+            <a:xfrm>
+              <a:off x="4852451" y="2690469"/>
+              <a:ext cx="400050" cy="400050"/>
+            </a:xfrm>
+            <a:prstGeom prst="ellipse">
+              <a:avLst/>
+            </a:prstGeom>
+            <a:solidFill>
+              <a:schemeClr val="tx1"/>
+            </a:solidFill>
+            <a:ln>
+              <a:noFill/>
+            </a:ln>
+          </p:spPr>
+          <p:style>
+            <a:lnRef idx="2">
+              <a:schemeClr val="accent1">
+                <a:shade val="15000"/>
+              </a:schemeClr>
+            </a:lnRef>
+            <a:fillRef idx="1">
+              <a:schemeClr val="accent1"/>
+            </a:fillRef>
+            <a:effectRef idx="0">
+              <a:schemeClr val="accent1"/>
+            </a:effectRef>
+            <a:fontRef idx="minor">
+              <a:schemeClr val="lt1"/>
+            </a:fontRef>
+          </p:style>
+          <p:txBody>
+            <a:bodyPr rtlCol="0" anchor="ctr"/>
+            <a:lstStyle/>
+            <a:p>
+              <a:pPr algn="ctr"/>
+              <a:endParaRPr lang="en-US" dirty="0"/>
+            </a:p>
+          </p:txBody>
+        </p:sp>
+        <p:pic>
+          <p:nvPicPr>
+            <p:cNvPr id="14" name="Picture 13" descr="A building with a red cross on it&#10;&#10;AI-generated content may be incorrect.">
+              <a:extLst>
+                <a:ext uri="{FF2B5EF4-FFF2-40B4-BE49-F238E27FC236}">
+                  <a16:creationId xmlns:a16="http://schemas.microsoft.com/office/drawing/2014/main" id="{55A00A89-460C-C4C6-32AA-9700FCFA08F8}"/>
+                </a:ext>
+              </a:extLst>
+            </p:cNvPr>
+            <p:cNvPicPr>
+              <a:picLocks noChangeAspect="1"/>
+            </p:cNvPicPr>
+            <p:nvPr/>
+          </p:nvPicPr>
+          <p:blipFill>
+            <a:blip r:embed="rId4">
+              <a:extLst>
+                <a:ext uri="{28A0092B-C50C-407E-A947-70E740481C1C}">
+                  <a14:useLocalDpi xmlns:a14="http://schemas.microsoft.com/office/drawing/2010/main" val="0"/>
+                </a:ext>
+              </a:extLst>
+            </a:blip>
+            <a:stretch>
+              <a:fillRect/>
+            </a:stretch>
+          </p:blipFill>
+          <p:spPr>
+            <a:xfrm>
+              <a:off x="3806899" y="2575930"/>
+              <a:ext cx="629128" cy="629128"/>
+            </a:xfrm>
+            <a:prstGeom prst="rect">
+              <a:avLst/>
+            </a:prstGeom>
+          </p:spPr>
+        </p:pic>
+        <p:sp>
+          <p:nvSpPr>
+            <p:cNvPr id="15" name="TextBox 14">
+              <a:extLst>
+                <a:ext uri="{FF2B5EF4-FFF2-40B4-BE49-F238E27FC236}">
+                  <a16:creationId xmlns:a16="http://schemas.microsoft.com/office/drawing/2014/main" id="{8BF3D476-DB49-85C0-9DAB-207E2659EFC5}"/>
+                </a:ext>
+              </a:extLst>
+            </p:cNvPr>
+            <p:cNvSpPr txBox="1"/>
+            <p:nvPr/>
+          </p:nvSpPr>
+          <p:spPr>
+            <a:xfrm>
+              <a:off x="1981026" y="3333750"/>
+              <a:ext cx="902970" cy="369332"/>
+            </a:xfrm>
+            <a:prstGeom prst="rect">
+              <a:avLst/>
+            </a:prstGeom>
+            <a:noFill/>
+          </p:spPr>
+          <p:txBody>
+            <a:bodyPr wrap="square" rtlCol="0">
+              <a:spAutoFit/>
+            </a:bodyPr>
+            <a:lstStyle/>
+            <a:p>
+              <a:pPr algn="ctr"/>
+              <a:r>
+                <a:rPr lang="en-US" dirty="0"/>
+                <a:t>Drone</a:t>
+              </a:r>
+            </a:p>
+          </p:txBody>
+        </p:sp>
+        <p:sp>
+          <p:nvSpPr>
+            <p:cNvPr id="16" name="TextBox 15">
+              <a:extLst>
+                <a:ext uri="{FF2B5EF4-FFF2-40B4-BE49-F238E27FC236}">
+                  <a16:creationId xmlns:a16="http://schemas.microsoft.com/office/drawing/2014/main" id="{F1F3EA8A-ECD2-4B7E-1438-D4D49E912280}"/>
+                </a:ext>
+              </a:extLst>
+            </p:cNvPr>
+            <p:cNvSpPr txBox="1"/>
+            <p:nvPr/>
+          </p:nvSpPr>
+          <p:spPr>
+            <a:xfrm>
+              <a:off x="2752366" y="3333750"/>
+              <a:ext cx="902970" cy="369332"/>
+            </a:xfrm>
+            <a:prstGeom prst="rect">
+              <a:avLst/>
+            </a:prstGeom>
+            <a:noFill/>
+          </p:spPr>
+          <p:txBody>
+            <a:bodyPr wrap="square" rtlCol="0">
+              <a:spAutoFit/>
+            </a:bodyPr>
+            <a:lstStyle/>
+            <a:p>
+              <a:pPr algn="ctr"/>
+              <a:r>
+                <a:rPr lang="en-US" dirty="0"/>
+                <a:t>GV</a:t>
+              </a:r>
+            </a:p>
+          </p:txBody>
+        </p:sp>
+        <p:sp>
+          <p:nvSpPr>
+            <p:cNvPr id="17" name="TextBox 16">
+              <a:extLst>
+                <a:ext uri="{FF2B5EF4-FFF2-40B4-BE49-F238E27FC236}">
+                  <a16:creationId xmlns:a16="http://schemas.microsoft.com/office/drawing/2014/main" id="{92B874CA-E42E-ADDA-4DEF-9B93342D5BA9}"/>
+                </a:ext>
+              </a:extLst>
+            </p:cNvPr>
+            <p:cNvSpPr txBox="1"/>
+            <p:nvPr/>
+          </p:nvSpPr>
+          <p:spPr>
+            <a:xfrm>
+              <a:off x="3601457" y="3333750"/>
+              <a:ext cx="1040011" cy="369332"/>
+            </a:xfrm>
+            <a:prstGeom prst="rect">
+              <a:avLst/>
+            </a:prstGeom>
+            <a:noFill/>
+          </p:spPr>
+          <p:txBody>
+            <a:bodyPr wrap="square" rtlCol="0">
+              <a:spAutoFit/>
+            </a:bodyPr>
+            <a:lstStyle/>
+            <a:p>
+              <a:pPr algn="ctr"/>
+              <a:r>
+                <a:rPr lang="en-US" dirty="0"/>
+                <a:t>Hospital</a:t>
+              </a:r>
+            </a:p>
+          </p:txBody>
+        </p:sp>
+        <p:sp>
+          <p:nvSpPr>
+            <p:cNvPr id="18" name="TextBox 17">
+              <a:extLst>
+                <a:ext uri="{FF2B5EF4-FFF2-40B4-BE49-F238E27FC236}">
+                  <a16:creationId xmlns:a16="http://schemas.microsoft.com/office/drawing/2014/main" id="{BE3C94F7-DE81-D704-A1BB-2F1F01320D2E}"/>
+                </a:ext>
+              </a:extLst>
+            </p:cNvPr>
+            <p:cNvSpPr txBox="1"/>
+            <p:nvPr/>
+          </p:nvSpPr>
+          <p:spPr>
+            <a:xfrm>
+              <a:off x="4497883" y="3333750"/>
+              <a:ext cx="1040011" cy="369332"/>
+            </a:xfrm>
+            <a:prstGeom prst="rect">
+              <a:avLst/>
+            </a:prstGeom>
+            <a:noFill/>
+          </p:spPr>
+          <p:txBody>
+            <a:bodyPr wrap="square" rtlCol="0">
+              <a:spAutoFit/>
+            </a:bodyPr>
+            <a:lstStyle/>
+            <a:p>
+              <a:pPr algn="ctr"/>
+              <a:r>
+                <a:rPr lang="en-US" dirty="0"/>
+                <a:t>Base</a:t>
+              </a:r>
+            </a:p>
+          </p:txBody>
+        </p:sp>
+        <p:sp>
+          <p:nvSpPr>
+            <p:cNvPr id="19" name="TextBox 18">
+              <a:extLst>
+                <a:ext uri="{FF2B5EF4-FFF2-40B4-BE49-F238E27FC236}">
+                  <a16:creationId xmlns:a16="http://schemas.microsoft.com/office/drawing/2014/main" id="{31188849-E506-82C2-FD6B-1FA29234C828}"/>
+                </a:ext>
+              </a:extLst>
+            </p:cNvPr>
+            <p:cNvSpPr txBox="1"/>
+            <p:nvPr/>
+          </p:nvSpPr>
+          <p:spPr>
+            <a:xfrm>
+              <a:off x="5437819" y="3333750"/>
+              <a:ext cx="1040011" cy="646331"/>
+            </a:xfrm>
+            <a:prstGeom prst="rect">
+              <a:avLst/>
+            </a:prstGeom>
+            <a:noFill/>
+          </p:spPr>
+          <p:txBody>
+            <a:bodyPr wrap="square" rtlCol="0">
+              <a:spAutoFit/>
+            </a:bodyPr>
+            <a:lstStyle/>
+            <a:p>
+              <a:pPr algn="ctr"/>
+              <a:r>
+                <a:rPr lang="en-US" dirty="0"/>
+                <a:t>Low</a:t>
+              </a:r>
+            </a:p>
+            <a:p>
+              <a:pPr algn="ctr"/>
+              <a:r>
+                <a:rPr lang="en-US" dirty="0"/>
+                <a:t>Priority</a:t>
+              </a:r>
+            </a:p>
+          </p:txBody>
+        </p:sp>
+        <p:sp>
+          <p:nvSpPr>
+            <p:cNvPr id="20" name="TextBox 19">
+              <a:extLst>
+                <a:ext uri="{FF2B5EF4-FFF2-40B4-BE49-F238E27FC236}">
+                  <a16:creationId xmlns:a16="http://schemas.microsoft.com/office/drawing/2014/main" id="{DDFC5678-C2EC-04D1-CA9E-C95CBEC9B6B7}"/>
+                </a:ext>
+              </a:extLst>
+            </p:cNvPr>
+            <p:cNvSpPr txBox="1"/>
+            <p:nvPr/>
+          </p:nvSpPr>
+          <p:spPr>
+            <a:xfrm>
+              <a:off x="6410789" y="3333750"/>
+              <a:ext cx="1040011" cy="646331"/>
+            </a:xfrm>
+            <a:prstGeom prst="rect">
+              <a:avLst/>
+            </a:prstGeom>
+            <a:noFill/>
+          </p:spPr>
+          <p:txBody>
+            <a:bodyPr wrap="square" rtlCol="0">
+              <a:spAutoFit/>
+            </a:bodyPr>
+            <a:lstStyle/>
+            <a:p>
+              <a:pPr algn="ctr"/>
+              <a:r>
+                <a:rPr lang="en-US" dirty="0"/>
+                <a:t>Medium</a:t>
+              </a:r>
+            </a:p>
+            <a:p>
+              <a:pPr algn="ctr"/>
+              <a:r>
+                <a:rPr lang="en-US" dirty="0"/>
+                <a:t>Priority</a:t>
+              </a:r>
+            </a:p>
+          </p:txBody>
+        </p:sp>
+        <p:sp>
+          <p:nvSpPr>
+            <p:cNvPr id="21" name="TextBox 20">
+              <a:extLst>
+                <a:ext uri="{FF2B5EF4-FFF2-40B4-BE49-F238E27FC236}">
+                  <a16:creationId xmlns:a16="http://schemas.microsoft.com/office/drawing/2014/main" id="{A1400B62-4CA1-4731-085D-E7DE75944EC6}"/>
+                </a:ext>
+              </a:extLst>
+            </p:cNvPr>
+            <p:cNvSpPr txBox="1"/>
+            <p:nvPr/>
+          </p:nvSpPr>
+          <p:spPr>
+            <a:xfrm>
+              <a:off x="7318937" y="3333750"/>
+              <a:ext cx="1040011" cy="646331"/>
+            </a:xfrm>
+            <a:prstGeom prst="rect">
+              <a:avLst/>
+            </a:prstGeom>
+            <a:noFill/>
+          </p:spPr>
+          <p:txBody>
+            <a:bodyPr wrap="square" rtlCol="0">
+              <a:spAutoFit/>
+            </a:bodyPr>
+            <a:lstStyle/>
+            <a:p>
+              <a:pPr algn="ctr"/>
+              <a:r>
+                <a:rPr lang="en-US" dirty="0"/>
+                <a:t>High</a:t>
+              </a:r>
+            </a:p>
+            <a:p>
+              <a:pPr algn="ctr"/>
+              <a:r>
+                <a:rPr lang="en-US" dirty="0"/>
+                <a:t>Priority</a:t>
+              </a:r>
+            </a:p>
+          </p:txBody>
+        </p:sp>
+        <p:sp>
+          <p:nvSpPr>
+            <p:cNvPr id="22" name="TextBox 21">
+              <a:extLst>
+                <a:ext uri="{FF2B5EF4-FFF2-40B4-BE49-F238E27FC236}">
+                  <a16:creationId xmlns:a16="http://schemas.microsoft.com/office/drawing/2014/main" id="{66F2D51D-87F6-55E4-19DD-73EBFA808EB1}"/>
+                </a:ext>
+              </a:extLst>
+            </p:cNvPr>
+            <p:cNvSpPr txBox="1"/>
+            <p:nvPr/>
+          </p:nvSpPr>
+          <p:spPr>
+            <a:xfrm>
+              <a:off x="8190585" y="3333750"/>
+              <a:ext cx="1040011" cy="646331"/>
+            </a:xfrm>
+            <a:prstGeom prst="rect">
+              <a:avLst/>
+            </a:prstGeom>
+            <a:noFill/>
+          </p:spPr>
+          <p:txBody>
+            <a:bodyPr wrap="square" rtlCol="0">
+              <a:spAutoFit/>
+            </a:bodyPr>
+            <a:lstStyle/>
+            <a:p>
+              <a:pPr algn="ctr"/>
+              <a:r>
+                <a:rPr lang="en-US" dirty="0"/>
+                <a:t>ATM Referred</a:t>
+              </a:r>
+            </a:p>
+          </p:txBody>
+        </p:sp>
+      </p:grpSp>
     </p:spTree>
     <p:extLst>
       <p:ext uri="{BB962C8B-B14F-4D97-AF65-F5344CB8AC3E}">

</xml_diff>

<commit_message>
Minor but many enhancements.
</commit_message>
<xml_diff>
--- a/examples/images/legend.pptx
+++ b/examples/images/legend.pptx
@@ -261,7 +261,7 @@
           <a:p>
             <a:fld id="{DC105BC4-7DAD-433D-880A-7855AECB43BC}" type="datetimeFigureOut">
               <a:rPr lang="en-US" smtClean="0"/>
-              <a:t>8/11/2025</a:t>
+              <a:t>8/12/2025</a:t>
             </a:fld>
             <a:endParaRPr lang="en-US"/>
           </a:p>
@@ -459,7 +459,7 @@
           <a:p>
             <a:fld id="{DC105BC4-7DAD-433D-880A-7855AECB43BC}" type="datetimeFigureOut">
               <a:rPr lang="en-US" smtClean="0"/>
-              <a:t>8/11/2025</a:t>
+              <a:t>8/12/2025</a:t>
             </a:fld>
             <a:endParaRPr lang="en-US"/>
           </a:p>
@@ -667,7 +667,7 @@
           <a:p>
             <a:fld id="{DC105BC4-7DAD-433D-880A-7855AECB43BC}" type="datetimeFigureOut">
               <a:rPr lang="en-US" smtClean="0"/>
-              <a:t>8/11/2025</a:t>
+              <a:t>8/12/2025</a:t>
             </a:fld>
             <a:endParaRPr lang="en-US"/>
           </a:p>
@@ -865,7 +865,7 @@
           <a:p>
             <a:fld id="{DC105BC4-7DAD-433D-880A-7855AECB43BC}" type="datetimeFigureOut">
               <a:rPr lang="en-US" smtClean="0"/>
-              <a:t>8/11/2025</a:t>
+              <a:t>8/12/2025</a:t>
             </a:fld>
             <a:endParaRPr lang="en-US"/>
           </a:p>
@@ -1140,7 +1140,7 @@
           <a:p>
             <a:fld id="{DC105BC4-7DAD-433D-880A-7855AECB43BC}" type="datetimeFigureOut">
               <a:rPr lang="en-US" smtClean="0"/>
-              <a:t>8/11/2025</a:t>
+              <a:t>8/12/2025</a:t>
             </a:fld>
             <a:endParaRPr lang="en-US"/>
           </a:p>
@@ -1405,7 +1405,7 @@
           <a:p>
             <a:fld id="{DC105BC4-7DAD-433D-880A-7855AECB43BC}" type="datetimeFigureOut">
               <a:rPr lang="en-US" smtClean="0"/>
-              <a:t>8/11/2025</a:t>
+              <a:t>8/12/2025</a:t>
             </a:fld>
             <a:endParaRPr lang="en-US"/>
           </a:p>
@@ -1817,7 +1817,7 @@
           <a:p>
             <a:fld id="{DC105BC4-7DAD-433D-880A-7855AECB43BC}" type="datetimeFigureOut">
               <a:rPr lang="en-US" smtClean="0"/>
-              <a:t>8/11/2025</a:t>
+              <a:t>8/12/2025</a:t>
             </a:fld>
             <a:endParaRPr lang="en-US"/>
           </a:p>
@@ -1958,7 +1958,7 @@
           <a:p>
             <a:fld id="{DC105BC4-7DAD-433D-880A-7855AECB43BC}" type="datetimeFigureOut">
               <a:rPr lang="en-US" smtClean="0"/>
-              <a:t>8/11/2025</a:t>
+              <a:t>8/12/2025</a:t>
             </a:fld>
             <a:endParaRPr lang="en-US"/>
           </a:p>
@@ -2071,7 +2071,7 @@
           <a:p>
             <a:fld id="{DC105BC4-7DAD-433D-880A-7855AECB43BC}" type="datetimeFigureOut">
               <a:rPr lang="en-US" smtClean="0"/>
-              <a:t>8/11/2025</a:t>
+              <a:t>8/12/2025</a:t>
             </a:fld>
             <a:endParaRPr lang="en-US"/>
           </a:p>
@@ -2382,7 +2382,7 @@
           <a:p>
             <a:fld id="{DC105BC4-7DAD-433D-880A-7855AECB43BC}" type="datetimeFigureOut">
               <a:rPr lang="en-US" smtClean="0"/>
-              <a:t>8/11/2025</a:t>
+              <a:t>8/12/2025</a:t>
             </a:fld>
             <a:endParaRPr lang="en-US"/>
           </a:p>
@@ -2670,7 +2670,7 @@
           <a:p>
             <a:fld id="{DC105BC4-7DAD-433D-880A-7855AECB43BC}" type="datetimeFigureOut">
               <a:rPr lang="en-US" smtClean="0"/>
-              <a:t>8/11/2025</a:t>
+              <a:t>8/12/2025</a:t>
             </a:fld>
             <a:endParaRPr lang="en-US"/>
           </a:p>
@@ -2911,7 +2911,7 @@
           <a:p>
             <a:fld id="{DC105BC4-7DAD-433D-880A-7855AECB43BC}" type="datetimeFigureOut">
               <a:rPr lang="en-US" smtClean="0"/>
-              <a:t>8/11/2025</a:t>
+              <a:t>8/12/2025</a:t>
             </a:fld>
             <a:endParaRPr lang="en-US"/>
           </a:p>
@@ -3343,9 +3343,9 @@
         <p:grpSpPr>
           <a:xfrm>
             <a:off x="1971675" y="2247900"/>
-            <a:ext cx="7269480" cy="1828800"/>
+            <a:ext cx="7316095" cy="1828800"/>
             <a:chOff x="1971675" y="2247900"/>
-            <a:chExt cx="7269480" cy="1828800"/>
+            <a:chExt cx="7316095" cy="1828800"/>
           </a:xfrm>
         </p:grpSpPr>
         <p:sp>
@@ -4061,7 +4061,7 @@
           </p:nvSpPr>
           <p:spPr>
             <a:xfrm>
-              <a:off x="8190585" y="3333750"/>
+              <a:off x="8247759" y="3333750"/>
               <a:ext cx="1040011" cy="646331"/>
             </a:xfrm>
             <a:prstGeom prst="rect">
@@ -4078,7 +4078,7 @@
               <a:pPr algn="ctr"/>
               <a:r>
                 <a:rPr lang="en-US" dirty="0"/>
-                <a:t>ATM Referred</a:t>
+                <a:t>ATM Alert</a:t>
               </a:r>
             </a:p>
           </p:txBody>

</xml_diff>